<commit_message>
added second review docs
</commit_message>
<xml_diff>
--- a/Docs/T076-CS23721-Project-Phase-I/PPT & Other Things/T075_Voice-Based_AI_Receptionist_Agent_Zeroth_Review.pptx
+++ b/Docs/T076-CS23721-Project-Phase-I/PPT & Other Things/T075_Voice-Based_AI_Receptionist_Agent_Zeroth_Review.pptx
@@ -343,7 +343,7 @@
           <a:p>
             <a:fld id="{4BDF68E2-58F2-4D09-BE8B-E3BD06533059}" type="datetimeFigureOut">
               <a:rPr lang="en-US" dirty="0"/>
-              <a:t>9/5/2026</a:t>
+              <a:t>9/6/2026</a:t>
             </a:fld>
             <a:endParaRPr lang="en-US" dirty="0"/>
           </a:p>
@@ -546,7 +546,7 @@
           <a:p>
             <a:fld id="{2E2D6473-DF6D-4702-B328-E0DD40540A4E}" type="datetimeFigureOut">
               <a:rPr lang="en-US" dirty="0"/>
-              <a:t>9/5/2026</a:t>
+              <a:t>9/6/2026</a:t>
             </a:fld>
             <a:endParaRPr lang="en-US" dirty="0"/>
           </a:p>
@@ -797,7 +797,7 @@
           <a:p>
             <a:fld id="{E26F7E3A-B166-407D-9866-32884E7D5B37}" type="datetimeFigureOut">
               <a:rPr lang="en-US" dirty="0"/>
-              <a:t>9/5/2026</a:t>
+              <a:t>9/6/2026</a:t>
             </a:fld>
             <a:endParaRPr lang="en-US" dirty="0"/>
           </a:p>
@@ -966,7 +966,7 @@
           <a:p>
             <a:fld id="{528FC5F6-F338-4AE4-BB23-26385BCFC423}" type="datetimeFigureOut">
               <a:rPr lang="en-US" dirty="0"/>
-              <a:t>9/5/2026</a:t>
+              <a:t>9/6/2026</a:t>
             </a:fld>
             <a:endParaRPr lang="en-US" dirty="0"/>
           </a:p>
@@ -1304,7 +1304,7 @@
           <a:p>
             <a:fld id="{20EBB0C4-6273-4C6E-B9BD-2EDC30F1CD52}" type="datetimeFigureOut">
               <a:rPr lang="en-US" dirty="0"/>
-              <a:t>9/5/2026</a:t>
+              <a:t>9/6/2026</a:t>
             </a:fld>
             <a:endParaRPr lang="en-US" dirty="0"/>
           </a:p>
@@ -1574,7 +1574,7 @@
           <a:p>
             <a:fld id="{19AB4D41-86C1-4908-B66A-0B50CEB3BF29}" type="datetimeFigureOut">
               <a:rPr lang="en-US" dirty="0"/>
-              <a:t>9/5/2026</a:t>
+              <a:t>9/6/2026</a:t>
             </a:fld>
             <a:endParaRPr lang="en-US" dirty="0"/>
           </a:p>
@@ -1948,7 +1948,7 @@
           <a:p>
             <a:fld id="{E6426E2C-56C1-4E0D-A793-0088A7FDD37E}" type="datetimeFigureOut">
               <a:rPr lang="en-US" dirty="0"/>
-              <a:t>9/5/2026</a:t>
+              <a:t>9/6/2026</a:t>
             </a:fld>
             <a:endParaRPr lang="en-US" dirty="0"/>
           </a:p>
@@ -2061,7 +2061,7 @@
           <a:p>
             <a:fld id="{C8C39B41-D8B5-4052-B551-9B5525EAA8B6}" type="datetimeFigureOut">
               <a:rPr lang="en-US" dirty="0"/>
-              <a:t>9/5/2026</a:t>
+              <a:t>9/6/2026</a:t>
             </a:fld>
             <a:endParaRPr lang="en-US" dirty="0"/>
           </a:p>
@@ -2227,7 +2227,7 @@
           <a:p>
             <a:fld id="{4D94136C-8742-45B2-AF27-D93DF72833A9}" type="datetimeFigureOut">
               <a:rPr lang="en-US" dirty="0"/>
-              <a:t>9/5/2026</a:t>
+              <a:t>9/6/2026</a:t>
             </a:fld>
             <a:endParaRPr lang="en-US" dirty="0"/>
           </a:p>
@@ -2577,7 +2577,7 @@
           <a:p>
             <a:fld id="{32ABBEA6-7C60-4B02-AE87-00D78D8422AF}" type="datetimeFigureOut">
               <a:rPr lang="en-US" dirty="0"/>
-              <a:t>9/5/2026</a:t>
+              <a:t>9/6/2026</a:t>
             </a:fld>
             <a:endParaRPr lang="en-US" dirty="0"/>
           </a:p>
@@ -2955,7 +2955,7 @@
           <a:p>
             <a:fld id="{C9CAD897-D46E-4AD2-BD9B-49DD3E640873}" type="datetimeFigureOut">
               <a:rPr lang="en-US" dirty="0"/>
-              <a:t>9/5/2026</a:t>
+              <a:t>9/6/2026</a:t>
             </a:fld>
             <a:endParaRPr lang="en-US" dirty="0"/>
           </a:p>
@@ -3237,7 +3237,7 @@
           <a:p>
             <a:fld id="{98624D31-43A5-475A-80CF-332C9F6DCF35}" type="datetimeFigureOut">
               <a:rPr lang="en-US" dirty="0"/>
-              <a:t>9/5/2026</a:t>
+              <a:t>9/6/2026</a:t>
             </a:fld>
             <a:endParaRPr lang="en-US" dirty="0"/>
           </a:p>
@@ -3899,7 +3899,7 @@
               <a:buNone/>
             </a:pPr>
             <a:r>
-              <a:rPr lang="en-IN" sz="1300" dirty="0">
+              <a:rPr lang="en-IN" sz="1300">
                 <a:solidFill>
                   <a:schemeClr val="tx1">
                     <a:lumMod val="75000"/>
@@ -3907,8 +3907,27 @@
                   </a:schemeClr>
                 </a:solidFill>
               </a:rPr>
-              <a:t>Zeroth Review</a:t>
-            </a:r>
+              <a:t>Zeroth </a:t>
+            </a:r>
+            <a:r>
+              <a:rPr lang="en-IN" sz="1300" smtClean="0">
+                <a:solidFill>
+                  <a:schemeClr val="tx1">
+                    <a:lumMod val="75000"/>
+                    <a:lumOff val="25000"/>
+                  </a:schemeClr>
+                </a:solidFill>
+              </a:rPr>
+              <a:t>Review PPT</a:t>
+            </a:r>
+            <a:endParaRPr lang="en-IN" sz="1300" dirty="0">
+              <a:solidFill>
+                <a:schemeClr val="tx1">
+                  <a:lumMod val="75000"/>
+                  <a:lumOff val="25000"/>
+                </a:schemeClr>
+              </a:solidFill>
+            </a:endParaRPr>
           </a:p>
         </p:txBody>
       </p:sp>
@@ -3917,7 +3936,7 @@
           <p:cNvPr id="2" name="Title 1">
             <a:extLst>
               <a:ext uri="{FF2B5EF4-FFF2-40B4-BE49-F238E27FC236}">
-                <a16:creationId xmlns:a16="http://schemas.microsoft.com/office/drawing/2014/main" xmlns="" id="{6733CD1E-B289-D636-DC22-E1AB1C986729}"/>
+                <a16:creationId xmlns="" xmlns:a16="http://schemas.microsoft.com/office/drawing/2014/main" id="{6733CD1E-B289-D636-DC22-E1AB1C986729}"/>
               </a:ext>
             </a:extLst>
           </p:cNvPr>
@@ -4548,7 +4567,7 @@
           <p:cNvPr id="2" name="Title 1">
             <a:extLst>
               <a:ext uri="{FF2B5EF4-FFF2-40B4-BE49-F238E27FC236}">
-                <a16:creationId xmlns:a16="http://schemas.microsoft.com/office/drawing/2014/main" xmlns="" id="{69059E6B-0867-76A7-05D9-E905568BD8AB}"/>
+                <a16:creationId xmlns="" xmlns:a16="http://schemas.microsoft.com/office/drawing/2014/main" id="{69059E6B-0867-76A7-05D9-E905568BD8AB}"/>
               </a:ext>
             </a:extLst>
           </p:cNvPr>
@@ -4582,7 +4601,7 @@
           <p:cNvPr id="3" name="Content Placeholder 2">
             <a:extLst>
               <a:ext uri="{FF2B5EF4-FFF2-40B4-BE49-F238E27FC236}">
-                <a16:creationId xmlns:a16="http://schemas.microsoft.com/office/drawing/2014/main" xmlns="" id="{BB48A27A-4629-30D5-8312-16BF411D31C5}"/>
+                <a16:creationId xmlns="" xmlns:a16="http://schemas.microsoft.com/office/drawing/2014/main" id="{BB48A27A-4629-30D5-8312-16BF411D31C5}"/>
               </a:ext>
             </a:extLst>
           </p:cNvPr>

</xml_diff>